<commit_message>
Rework Slide2 into megatrend→設備→製造業→focus-on-AI framing
P2のメッセージを刷新：世界のメガトレンド（AI・脱炭素GX・経済安保/国内回帰）は
どれも膨大な「設備」を必要とし、その設備の主役は建設業だけでなく製造業がコア。
市場は圧倒的に拡大＝乗るしかない → 今日はAIにフォーカス、というズームイン構成。
AIカードのみ赤＋「本日フォーカス」タグで視線誘導。

Co-Authored-By: Claude Opus 4.8 <noreply@anthropic.com>
Claude-Session: https://claude.ai/code/session_019kp2xQ2MF7K6NspMRsdcH4
</commit_message>
<xml_diff>
--- a/output/andpad_soukai_ai_deck.pptx
+++ b/output/andpad_soukai_ai_deck.pptx
@@ -3873,7 +3873,7 @@
                 <a:latin typeface="Consolas"/>
                 <a:ea typeface="Consolas"/>
               </a:rPr>
-              <a:t>なぜ、いま製造業がアツいのか</a:t>
+              <a:t>世界のメガトレンドと、その“共通の土台”</a:t>
             </a:r>
           </a:p>
         </p:txBody>
@@ -3919,7 +3919,7 @@
                 <a:latin typeface="Noto Sans JP"/>
                 <a:ea typeface="Noto Sans JP"/>
               </a:rPr>
-              <a:t>AIブームは“クラウドの話”ではない。電気と鉄と現場の話だ。</a:t>
+              <a:t>世界が動く先には、必ず「設備」がいる。その主役は、製造業だ。</a:t>
             </a:r>
           </a:p>
         </p:txBody>
@@ -3976,8 +3976,8 @@
         </p:nvSpPr>
         <p:spPr>
           <a:xfrm>
-            <a:off x="777240" y="1481328"/>
-            <a:ext cx="3429000" cy="1783080"/>
+            <a:off x="777240" y="1417320"/>
+            <a:ext cx="3429000" cy="1965960"/>
           </a:xfrm>
           <a:prstGeom prst="roundRect">
             <a:avLst>
@@ -3987,7 +3987,7 @@
           <a:solidFill>
             <a:srgbClr val="FFFFFF"/>
           </a:solidFill>
-          <a:ln w="15240">
+          <a:ln w="20320">
             <a:solidFill>
               <a:srgbClr val="F3C7CD"/>
             </a:solidFill>
@@ -4024,8 +4024,8 @@
         </p:nvSpPr>
         <p:spPr>
           <a:xfrm>
-            <a:off x="777240" y="1481328"/>
-            <a:ext cx="3429000" cy="91440"/>
+            <a:off x="777240" y="1417320"/>
+            <a:ext cx="3429000" cy="512064"/>
           </a:xfrm>
           <a:prstGeom prst="roundRect">
             <a:avLst>
@@ -4070,8 +4070,8 @@
         </p:nvSpPr>
         <p:spPr>
           <a:xfrm>
-            <a:off x="1033271" y="1737360"/>
-            <a:ext cx="2916936" cy="1417319"/>
+            <a:off x="978408" y="1417320"/>
+            <a:ext cx="3063240" cy="512064"/>
           </a:xfrm>
           <a:prstGeom prst="rect">
             <a:avLst/>
@@ -4079,150 +4079,56 @@
           <a:noFill/>
         </p:spPr>
         <p:txBody>
-          <a:bodyPr wrap="square" anchor="t" lIns="0" rIns="0" tIns="0" bIns="0">
+          <a:bodyPr wrap="square" anchor="ctr" lIns="0" rIns="0" tIns="0" bIns="0">
             <a:spAutoFit/>
           </a:bodyPr>
           <a:lstStyle/>
           <a:p>
             <a:pPr algn="l">
               <a:lnSpc>
-                <a:spcPct val="116000"/>
-              </a:lnSpc>
-              <a:spcBef>
-                <a:spcPts val="0"/>
-              </a:spcBef>
-              <a:spcAft>
-                <a:spcPts val="700"/>
-              </a:spcAft>
-            </a:pPr>
-            <a:r>
-              <a:rPr sz="1050" b="1" spc="100">
-                <a:solidFill>
-                  <a:srgbClr val="E60012"/>
-                </a:solidFill>
-                <a:latin typeface="Consolas"/>
-                <a:ea typeface="Consolas"/>
-              </a:rPr>
-              <a:t>きっかけ</a:t>
-            </a:r>
-          </a:p>
-          <a:p>
-            <a:pPr algn="l">
-              <a:lnSpc>
-                <a:spcPct val="116000"/>
-              </a:lnSpc>
-              <a:spcBef>
-                <a:spcPts val="0"/>
-              </a:spcBef>
-              <a:spcAft>
-                <a:spcPts val="700"/>
-              </a:spcAft>
-            </a:pPr>
-            <a:r>
-              <a:rPr sz="1600" b="1">
-                <a:solidFill>
-                  <a:srgbClr val="1A1D21"/>
+                <a:spcPct val="106000"/>
+              </a:lnSpc>
+              <a:spcBef>
+                <a:spcPts val="0"/>
+              </a:spcBef>
+              <a:spcAft>
+                <a:spcPts val="400"/>
+              </a:spcAft>
+            </a:pPr>
+            <a:r>
+              <a:rPr sz="1450" b="1">
+                <a:solidFill>
+                  <a:srgbClr val="FFFFFF"/>
                 </a:solidFill>
                 <a:latin typeface="Noto Sans JP"/>
                 <a:ea typeface="Noto Sans JP"/>
               </a:rPr>
-              <a:t>AIは“電気と設備の塊”</a:t>
-            </a:r>
-          </a:p>
-          <a:p>
-            <a:pPr algn="l">
-              <a:lnSpc>
-                <a:spcPct val="116000"/>
-              </a:lnSpc>
-              <a:spcBef>
-                <a:spcPts val="0"/>
-              </a:spcBef>
-              <a:spcAft>
-                <a:spcPts val="700"/>
-              </a:spcAft>
-            </a:pPr>
-            <a:r>
-              <a:rPr sz="1150" b="0">
-                <a:solidFill>
-                  <a:srgbClr val="3C4148"/>
-                </a:solidFill>
-                <a:latin typeface="Noto Sans JP"/>
-                <a:ea typeface="Noto Sans JP"/>
-              </a:rPr>
-              <a:t>DC（データセンター）1棟で数万世帯分の電力。膨大な発電・変圧器・冷却・半導体が要る。</a:t>
-            </a:r>
-          </a:p>
-        </p:txBody>
-      </p:sp>
-      <p:sp>
-        <p:nvSpPr>
-          <p:cNvPr id="11" name="TextBox 10"/>
-          <p:cNvSpPr txBox="1"/>
-          <p:nvPr/>
-        </p:nvSpPr>
-        <p:spPr>
-          <a:xfrm>
-            <a:off x="4178807" y="1984248"/>
-            <a:ext cx="329184" cy="548640"/>
-          </a:xfrm>
-          <a:prstGeom prst="rect">
-            <a:avLst/>
-          </a:prstGeom>
-          <a:noFill/>
-        </p:spPr>
-        <p:txBody>
-          <a:bodyPr wrap="square" anchor="t" lIns="0" rIns="0" tIns="0" bIns="0">
-            <a:spAutoFit/>
-          </a:bodyPr>
-          <a:lstStyle/>
-          <a:p>
-            <a:pPr algn="ctr">
-              <a:lnSpc>
-                <a:spcPct val="106000"/>
-              </a:lnSpc>
-              <a:spcBef>
-                <a:spcPts val="0"/>
-              </a:spcBef>
-              <a:spcAft>
-                <a:spcPts val="400"/>
-              </a:spcAft>
-            </a:pPr>
-            <a:r>
-              <a:rPr sz="2200" b="1">
-                <a:solidFill>
-                  <a:srgbClr val="E60012"/>
-                </a:solidFill>
-                <a:latin typeface="Consolas"/>
-                <a:ea typeface="Consolas"/>
-              </a:rPr>
-              <a:t>→</a:t>
-            </a:r>
-          </a:p>
-        </p:txBody>
-      </p:sp>
-      <p:sp>
-        <p:nvSpPr>
-          <p:cNvPr id="12" name="Rounded Rectangle 11"/>
+              <a:t>① AI</a:t>
+            </a:r>
+          </a:p>
+        </p:txBody>
+      </p:sp>
+      <p:sp>
+        <p:nvSpPr>
+          <p:cNvPr id="11" name="Rounded Rectangle 10"/>
           <p:cNvSpPr/>
           <p:nvPr/>
         </p:nvSpPr>
         <p:spPr>
           <a:xfrm>
-            <a:off x="4480559" y="1481328"/>
-            <a:ext cx="3429000" cy="1783080"/>
+            <a:off x="2907791" y="1549908"/>
+            <a:ext cx="1133856" cy="246888"/>
           </a:xfrm>
           <a:prstGeom prst="roundRect">
             <a:avLst>
-              <a:gd name="adj" fmla="val 6000"/>
+              <a:gd name="adj" fmla="val 40000"/>
             </a:avLst>
           </a:prstGeom>
           <a:solidFill>
             <a:srgbClr val="FFFFFF"/>
           </a:solidFill>
-          <a:ln w="15240">
-            <a:solidFill>
-              <a:srgbClr val="F3C7CD"/>
-            </a:solidFill>
+          <a:ln>
+            <a:noFill/>
           </a:ln>
           <a:effectLst/>
         </p:spPr>
@@ -4250,14 +4156,200 @@
       </p:sp>
       <p:sp>
         <p:nvSpPr>
-          <p:cNvPr id="13" name="Rounded Rectangle 12"/>
+          <p:cNvPr id="12" name="TextBox 11"/>
+          <p:cNvSpPr txBox="1"/>
+          <p:nvPr/>
+        </p:nvSpPr>
+        <p:spPr>
+          <a:xfrm>
+            <a:off x="2907791" y="1549908"/>
+            <a:ext cx="1133856" cy="246888"/>
+          </a:xfrm>
+          <a:prstGeom prst="rect">
+            <a:avLst/>
+          </a:prstGeom>
+          <a:noFill/>
+        </p:spPr>
+        <p:txBody>
+          <a:bodyPr wrap="square" anchor="ctr" lIns="0" rIns="0" tIns="0" bIns="0">
+            <a:spAutoFit/>
+          </a:bodyPr>
+          <a:lstStyle/>
+          <a:p>
+            <a:pPr algn="ctr">
+              <a:lnSpc>
+                <a:spcPct val="106000"/>
+              </a:lnSpc>
+              <a:spcBef>
+                <a:spcPts val="0"/>
+              </a:spcBef>
+              <a:spcAft>
+                <a:spcPts val="400"/>
+              </a:spcAft>
+            </a:pPr>
+            <a:r>
+              <a:rPr sz="850" b="1">
+                <a:solidFill>
+                  <a:srgbClr val="E60012"/>
+                </a:solidFill>
+                <a:latin typeface="Consolas"/>
+                <a:ea typeface="Consolas"/>
+              </a:rPr>
+              <a:t>本日フォーカス</a:t>
+            </a:r>
+          </a:p>
+        </p:txBody>
+      </p:sp>
+      <p:sp>
+        <p:nvSpPr>
+          <p:cNvPr id="13" name="TextBox 12"/>
+          <p:cNvSpPr txBox="1"/>
+          <p:nvPr/>
+        </p:nvSpPr>
+        <p:spPr>
+          <a:xfrm>
+            <a:off x="996695" y="2093976"/>
+            <a:ext cx="2990088" cy="502920"/>
+          </a:xfrm>
+          <a:prstGeom prst="rect">
+            <a:avLst/>
+          </a:prstGeom>
+          <a:noFill/>
+        </p:spPr>
+        <p:txBody>
+          <a:bodyPr wrap="square" anchor="t" lIns="0" rIns="0" tIns="0" bIns="0">
+            <a:spAutoFit/>
+          </a:bodyPr>
+          <a:lstStyle/>
+          <a:p>
+            <a:pPr algn="l">
+              <a:lnSpc>
+                <a:spcPct val="114000"/>
+              </a:lnSpc>
+              <a:spcBef>
+                <a:spcPts val="0"/>
+              </a:spcBef>
+              <a:spcAft>
+                <a:spcPts val="400"/>
+              </a:spcAft>
+            </a:pPr>
+            <a:r>
+              <a:rPr sz="1350" b="1">
+                <a:solidFill>
+                  <a:srgbClr val="1A1D21"/>
+                </a:solidFill>
+                <a:latin typeface="Noto Sans JP"/>
+                <a:ea typeface="Noto Sans JP"/>
+              </a:rPr>
+              <a:t>生成AI・データセンター・半導体</a:t>
+            </a:r>
+          </a:p>
+        </p:txBody>
+      </p:sp>
+      <p:sp>
+        <p:nvSpPr>
+          <p:cNvPr id="14" name="TextBox 13"/>
+          <p:cNvSpPr txBox="1"/>
+          <p:nvPr/>
+        </p:nvSpPr>
+        <p:spPr>
+          <a:xfrm>
+            <a:off x="996695" y="2715768"/>
+            <a:ext cx="2990088" cy="548640"/>
+          </a:xfrm>
+          <a:prstGeom prst="rect">
+            <a:avLst/>
+          </a:prstGeom>
+          <a:noFill/>
+        </p:spPr>
+        <p:txBody>
+          <a:bodyPr wrap="square" anchor="t" lIns="0" rIns="0" tIns="0" bIns="0">
+            <a:spAutoFit/>
+          </a:bodyPr>
+          <a:lstStyle/>
+          <a:p>
+            <a:pPr algn="l">
+              <a:lnSpc>
+                <a:spcPct val="116000"/>
+              </a:lnSpc>
+              <a:spcBef>
+                <a:spcPts val="0"/>
+              </a:spcBef>
+              <a:spcAft>
+                <a:spcPts val="400"/>
+              </a:spcAft>
+            </a:pPr>
+            <a:r>
+              <a:rPr sz="1150" b="1">
+                <a:solidFill>
+                  <a:srgbClr val="E60012"/>
+                </a:solidFill>
+                <a:latin typeface="Noto Sans JP"/>
+                <a:ea typeface="Noto Sans JP"/>
+              </a:rPr>
+              <a:t>→ 電源・冷却・建屋・チップ工場が大量に要る</a:t>
+            </a:r>
+          </a:p>
+        </p:txBody>
+      </p:sp>
+      <p:sp>
+        <p:nvSpPr>
+          <p:cNvPr id="15" name="Rounded Rectangle 14"/>
           <p:cNvSpPr/>
           <p:nvPr/>
         </p:nvSpPr>
         <p:spPr>
           <a:xfrm>
-            <a:off x="4480559" y="1481328"/>
-            <a:ext cx="3429000" cy="91440"/>
+            <a:off x="4379976" y="1417320"/>
+            <a:ext cx="3429000" cy="1965960"/>
+          </a:xfrm>
+          <a:prstGeom prst="roundRect">
+            <a:avLst>
+              <a:gd name="adj" fmla="val 6000"/>
+            </a:avLst>
+          </a:prstGeom>
+          <a:solidFill>
+            <a:srgbClr val="FFFFFF"/>
+          </a:solidFill>
+          <a:ln w="12700">
+            <a:solidFill>
+              <a:srgbClr val="E2E4E9"/>
+            </a:solidFill>
+          </a:ln>
+          <a:effectLst/>
+        </p:spPr>
+        <p:style>
+          <a:lnRef idx="1">
+            <a:schemeClr val="accent1"/>
+          </a:lnRef>
+          <a:fillRef idx="3">
+            <a:schemeClr val="accent1"/>
+          </a:fillRef>
+          <a:effectRef idx="2">
+            <a:schemeClr val="accent1"/>
+          </a:effectRef>
+          <a:fontRef idx="minor">
+            <a:schemeClr val="lt1"/>
+          </a:fontRef>
+        </p:style>
+        <p:txBody>
+          <a:bodyPr rtlCol="0" anchor="ctr"/>
+          <a:lstStyle/>
+          <a:p>
+            <a:pPr algn="ctr"/>
+          </a:p>
+        </p:txBody>
+      </p:sp>
+      <p:sp>
+        <p:nvSpPr>
+          <p:cNvPr id="16" name="Rounded Rectangle 15"/>
+          <p:cNvSpPr/>
+          <p:nvPr/>
+        </p:nvSpPr>
+        <p:spPr>
+          <a:xfrm>
+            <a:off x="4379976" y="1417320"/>
+            <a:ext cx="3429000" cy="512064"/>
           </a:xfrm>
           <a:prstGeom prst="roundRect">
             <a:avLst>
@@ -4265,7 +4357,7 @@
             </a:avLst>
           </a:prstGeom>
           <a:solidFill>
-            <a:srgbClr val="E60012"/>
+            <a:srgbClr val="454B54"/>
           </a:solidFill>
           <a:ln>
             <a:noFill/>
@@ -4296,14 +4388,60 @@
       </p:sp>
       <p:sp>
         <p:nvSpPr>
-          <p:cNvPr id="14" name="TextBox 13"/>
+          <p:cNvPr id="17" name="TextBox 16"/>
           <p:cNvSpPr txBox="1"/>
           <p:nvPr/>
         </p:nvSpPr>
         <p:spPr>
           <a:xfrm>
-            <a:off x="4736592" y="1737360"/>
-            <a:ext cx="2916936" cy="1417319"/>
+            <a:off x="4581144" y="1417320"/>
+            <a:ext cx="3063240" cy="512064"/>
+          </a:xfrm>
+          <a:prstGeom prst="rect">
+            <a:avLst/>
+          </a:prstGeom>
+          <a:noFill/>
+        </p:spPr>
+        <p:txBody>
+          <a:bodyPr wrap="square" anchor="ctr" lIns="0" rIns="0" tIns="0" bIns="0">
+            <a:spAutoFit/>
+          </a:bodyPr>
+          <a:lstStyle/>
+          <a:p>
+            <a:pPr algn="l">
+              <a:lnSpc>
+                <a:spcPct val="106000"/>
+              </a:lnSpc>
+              <a:spcBef>
+                <a:spcPts val="0"/>
+              </a:spcBef>
+              <a:spcAft>
+                <a:spcPts val="400"/>
+              </a:spcAft>
+            </a:pPr>
+            <a:r>
+              <a:rPr sz="1450" b="1">
+                <a:solidFill>
+                  <a:srgbClr val="FFFFFF"/>
+                </a:solidFill>
+                <a:latin typeface="Noto Sans JP"/>
+                <a:ea typeface="Noto Sans JP"/>
+              </a:rPr>
+              <a:t>② 脱炭素（GX）</a:t>
+            </a:r>
+          </a:p>
+        </p:txBody>
+      </p:sp>
+      <p:sp>
+        <p:nvSpPr>
+          <p:cNvPr id="18" name="TextBox 17"/>
+          <p:cNvSpPr txBox="1"/>
+          <p:nvPr/>
+        </p:nvSpPr>
+        <p:spPr>
+          <a:xfrm>
+            <a:off x="4599432" y="2093976"/>
+            <a:ext cx="2990088" cy="502920"/>
           </a:xfrm>
           <a:prstGeom prst="rect">
             <a:avLst/>
@@ -4318,84 +4456,38 @@
           <a:p>
             <a:pPr algn="l">
               <a:lnSpc>
-                <a:spcPct val="116000"/>
-              </a:lnSpc>
-              <a:spcBef>
-                <a:spcPts val="0"/>
-              </a:spcBef>
-              <a:spcAft>
-                <a:spcPts val="700"/>
-              </a:spcAft>
-            </a:pPr>
-            <a:r>
-              <a:rPr sz="1050" b="1" spc="100">
-                <a:solidFill>
-                  <a:srgbClr val="E60012"/>
-                </a:solidFill>
-                <a:latin typeface="Consolas"/>
-                <a:ea typeface="Consolas"/>
-              </a:rPr>
-              <a:t>連鎖</a:t>
-            </a:r>
-          </a:p>
-          <a:p>
-            <a:pPr algn="l">
-              <a:lnSpc>
-                <a:spcPct val="116000"/>
-              </a:lnSpc>
-              <a:spcBef>
-                <a:spcPts val="0"/>
-              </a:spcBef>
-              <a:spcAft>
-                <a:spcPts val="700"/>
-              </a:spcAft>
-            </a:pPr>
-            <a:r>
-              <a:rPr sz="1600" b="1">
+                <a:spcPct val="114000"/>
+              </a:lnSpc>
+              <a:spcBef>
+                <a:spcPts val="0"/>
+              </a:spcBef>
+              <a:spcAft>
+                <a:spcPts val="400"/>
+              </a:spcAft>
+            </a:pPr>
+            <a:r>
+              <a:rPr sz="1350" b="1">
                 <a:solidFill>
                   <a:srgbClr val="1A1D21"/>
                 </a:solidFill>
                 <a:latin typeface="Noto Sans JP"/>
                 <a:ea typeface="Noto Sans JP"/>
               </a:rPr>
-              <a:t>製造業が一斉に動き出す</a:t>
-            </a:r>
-          </a:p>
-          <a:p>
-            <a:pPr algn="l">
-              <a:lnSpc>
-                <a:spcPct val="116000"/>
-              </a:lnSpc>
-              <a:spcBef>
-                <a:spcPts val="0"/>
-              </a:spcBef>
-              <a:spcAft>
-                <a:spcPts val="700"/>
-              </a:spcAft>
-            </a:pPr>
-            <a:r>
-              <a:rPr sz="1150" b="0">
-                <a:solidFill>
-                  <a:srgbClr val="3C4148"/>
-                </a:solidFill>
-                <a:latin typeface="Noto Sans JP"/>
-                <a:ea typeface="Noto Sans JP"/>
-              </a:rPr>
-              <a:t>重電・電線・空調・UPS・半導体——各社が工場を増設し、機器の製造・納入・据付が全国で立ち上がる。</a:t>
-            </a:r>
-          </a:p>
-        </p:txBody>
-      </p:sp>
-      <p:sp>
-        <p:nvSpPr>
-          <p:cNvPr id="15" name="TextBox 14"/>
+              <a:t>再エネ・送電網・電化・蓄電池</a:t>
+            </a:r>
+          </a:p>
+        </p:txBody>
+      </p:sp>
+      <p:sp>
+        <p:nvSpPr>
+          <p:cNvPr id="19" name="TextBox 18"/>
           <p:cNvSpPr txBox="1"/>
           <p:nvPr/>
         </p:nvSpPr>
         <p:spPr>
           <a:xfrm>
-            <a:off x="7882127" y="1984248"/>
-            <a:ext cx="329184" cy="548640"/>
+            <a:off x="4599432" y="2715768"/>
+            <a:ext cx="2990088" cy="548640"/>
           </a:xfrm>
           <a:prstGeom prst="rect">
             <a:avLst/>
@@ -4408,9 +4500,9 @@
           </a:bodyPr>
           <a:lstStyle/>
           <a:p>
-            <a:pPr algn="ctr">
-              <a:lnSpc>
-                <a:spcPct val="106000"/>
+            <a:pPr algn="l">
+              <a:lnSpc>
+                <a:spcPct val="116000"/>
               </a:lnSpc>
               <a:spcBef>
                 <a:spcPts val="0"/>
@@ -4420,28 +4512,28 @@
               </a:spcAft>
             </a:pPr>
             <a:r>
-              <a:rPr sz="2200" b="1">
-                <a:solidFill>
-                  <a:srgbClr val="E60012"/>
-                </a:solidFill>
-                <a:latin typeface="Consolas"/>
-                <a:ea typeface="Consolas"/>
-              </a:rPr>
-              <a:t>→</a:t>
-            </a:r>
-          </a:p>
-        </p:txBody>
-      </p:sp>
-      <p:sp>
-        <p:nvSpPr>
-          <p:cNvPr id="16" name="Rounded Rectangle 15"/>
+              <a:rPr sz="1150" b="0">
+                <a:solidFill>
+                  <a:srgbClr val="3C4148"/>
+                </a:solidFill>
+                <a:latin typeface="Noto Sans JP"/>
+                <a:ea typeface="Noto Sans JP"/>
+              </a:rPr>
+              <a:t>→ 発電・変電・ケーブル・電池／EV工場</a:t>
+            </a:r>
+          </a:p>
+        </p:txBody>
+      </p:sp>
+      <p:sp>
+        <p:nvSpPr>
+          <p:cNvPr id="20" name="Rounded Rectangle 19"/>
           <p:cNvSpPr/>
           <p:nvPr/>
         </p:nvSpPr>
         <p:spPr>
           <a:xfrm>
-            <a:off x="8183879" y="1481328"/>
-            <a:ext cx="3429000" cy="1783080"/>
+            <a:off x="7982712" y="1417320"/>
+            <a:ext cx="3429000" cy="1965960"/>
           </a:xfrm>
           <a:prstGeom prst="roundRect">
             <a:avLst>
@@ -4451,9 +4543,9 @@
           <a:solidFill>
             <a:srgbClr val="FFFFFF"/>
           </a:solidFill>
-          <a:ln w="15240">
+          <a:ln w="12700">
             <a:solidFill>
-              <a:srgbClr val="F3C7CD"/>
+              <a:srgbClr val="E2E4E9"/>
             </a:solidFill>
           </a:ln>
           <a:effectLst/>
@@ -4482,14 +4574,14 @@
       </p:sp>
       <p:sp>
         <p:nvSpPr>
-          <p:cNvPr id="17" name="Rounded Rectangle 16"/>
+          <p:cNvPr id="21" name="Rounded Rectangle 20"/>
           <p:cNvSpPr/>
           <p:nvPr/>
         </p:nvSpPr>
         <p:spPr>
           <a:xfrm>
-            <a:off x="8183879" y="1481328"/>
-            <a:ext cx="3429000" cy="91440"/>
+            <a:off x="7982712" y="1417320"/>
+            <a:ext cx="3429000" cy="512064"/>
           </a:xfrm>
           <a:prstGeom prst="roundRect">
             <a:avLst>
@@ -4497,7 +4589,7 @@
             </a:avLst>
           </a:prstGeom>
           <a:solidFill>
-            <a:srgbClr val="E60012"/>
+            <a:srgbClr val="454B54"/>
           </a:solidFill>
           <a:ln>
             <a:noFill/>
@@ -4528,14 +4620,60 @@
       </p:sp>
       <p:sp>
         <p:nvSpPr>
-          <p:cNvPr id="18" name="TextBox 17"/>
+          <p:cNvPr id="22" name="TextBox 21"/>
           <p:cNvSpPr txBox="1"/>
           <p:nvPr/>
         </p:nvSpPr>
         <p:spPr>
           <a:xfrm>
-            <a:off x="8439911" y="1737360"/>
-            <a:ext cx="2916936" cy="1417319"/>
+            <a:off x="8183880" y="1417320"/>
+            <a:ext cx="3063240" cy="512064"/>
+          </a:xfrm>
+          <a:prstGeom prst="rect">
+            <a:avLst/>
+          </a:prstGeom>
+          <a:noFill/>
+        </p:spPr>
+        <p:txBody>
+          <a:bodyPr wrap="square" anchor="ctr" lIns="0" rIns="0" tIns="0" bIns="0">
+            <a:spAutoFit/>
+          </a:bodyPr>
+          <a:lstStyle/>
+          <a:p>
+            <a:pPr algn="l">
+              <a:lnSpc>
+                <a:spcPct val="106000"/>
+              </a:lnSpc>
+              <a:spcBef>
+                <a:spcPts val="0"/>
+              </a:spcBef>
+              <a:spcAft>
+                <a:spcPts val="400"/>
+              </a:spcAft>
+            </a:pPr>
+            <a:r>
+              <a:rPr sz="1450" b="1">
+                <a:solidFill>
+                  <a:srgbClr val="FFFFFF"/>
+                </a:solidFill>
+                <a:latin typeface="Noto Sans JP"/>
+                <a:ea typeface="Noto Sans JP"/>
+              </a:rPr>
+              <a:t>③ 経済安保・国内回帰</a:t>
+            </a:r>
+          </a:p>
+        </p:txBody>
+      </p:sp>
+      <p:sp>
+        <p:nvSpPr>
+          <p:cNvPr id="23" name="TextBox 22"/>
+          <p:cNvSpPr txBox="1"/>
+          <p:nvPr/>
+        </p:nvSpPr>
+        <p:spPr>
+          <a:xfrm>
+            <a:off x="8202168" y="2093976"/>
+            <a:ext cx="2990088" cy="502920"/>
           </a:xfrm>
           <a:prstGeom prst="rect">
             <a:avLst/>
@@ -4550,49 +4688,49 @@
           <a:p>
             <a:pPr algn="l">
               <a:lnSpc>
-                <a:spcPct val="116000"/>
-              </a:lnSpc>
-              <a:spcBef>
-                <a:spcPts val="0"/>
-              </a:spcBef>
-              <a:spcAft>
-                <a:spcPts val="700"/>
-              </a:spcAft>
-            </a:pPr>
-            <a:r>
-              <a:rPr sz="1050" b="1" spc="100">
-                <a:solidFill>
-                  <a:srgbClr val="E60012"/>
-                </a:solidFill>
-                <a:latin typeface="Consolas"/>
-                <a:ea typeface="Consolas"/>
-              </a:rPr>
-              <a:t>結果</a:t>
-            </a:r>
-          </a:p>
-          <a:p>
-            <a:pPr algn="l">
-              <a:lnSpc>
-                <a:spcPct val="116000"/>
-              </a:lnSpc>
-              <a:spcBef>
-                <a:spcPts val="0"/>
-              </a:spcBef>
-              <a:spcAft>
-                <a:spcPts val="700"/>
-              </a:spcAft>
-            </a:pPr>
-            <a:r>
-              <a:rPr sz="1600" b="1">
+                <a:spcPct val="114000"/>
+              </a:lnSpc>
+              <a:spcBef>
+                <a:spcPts val="0"/>
+              </a:spcBef>
+              <a:spcAft>
+                <a:spcPts val="400"/>
+              </a:spcAft>
+            </a:pPr>
+            <a:r>
+              <a:rPr sz="1350" b="1">
                 <a:solidFill>
                   <a:srgbClr val="1A1D21"/>
                 </a:solidFill>
                 <a:latin typeface="Noto Sans JP"/>
                 <a:ea typeface="Noto Sans JP"/>
               </a:rPr>
-              <a:t>“現場”が全国で急増する</a:t>
-            </a:r>
-          </a:p>
+              <a:t>半導体・重要物資の国産化</a:t>
+            </a:r>
+          </a:p>
+        </p:txBody>
+      </p:sp>
+      <p:sp>
+        <p:nvSpPr>
+          <p:cNvPr id="24" name="TextBox 23"/>
+          <p:cNvSpPr txBox="1"/>
+          <p:nvPr/>
+        </p:nvSpPr>
+        <p:spPr>
+          <a:xfrm>
+            <a:off x="8202168" y="2715768"/>
+            <a:ext cx="2990088" cy="548640"/>
+          </a:xfrm>
+          <a:prstGeom prst="rect">
+            <a:avLst/>
+          </a:prstGeom>
+          <a:noFill/>
+        </p:spPr>
+        <p:txBody>
+          <a:bodyPr wrap="square" anchor="t" lIns="0" rIns="0" tIns="0" bIns="0">
+            <a:spAutoFit/>
+          </a:bodyPr>
+          <a:lstStyle/>
           <a:p>
             <a:pPr algn="l">
               <a:lnSpc>
@@ -4602,7 +4740,7 @@
                 <a:spcPts val="0"/>
               </a:spcBef>
               <a:spcAft>
-                <a:spcPts val="700"/>
+                <a:spcPts val="400"/>
               </a:spcAft>
             </a:pPr>
             <a:r>
@@ -4613,14 +4751,14 @@
                 <a:latin typeface="Noto Sans JP"/>
                 <a:ea typeface="Noto Sans JP"/>
               </a:rPr>
-              <a:t>工場を建てる現場も、機器を据え付け・試運転・保守する現場も、同時多発で増えていく。</a:t>
-            </a:r>
-          </a:p>
-        </p:txBody>
-      </p:sp>
-      <p:sp>
-        <p:nvSpPr>
-          <p:cNvPr id="19" name="Rounded Rectangle 18"/>
+              <a:t>→ 国内に工場を新設し、供給網を再構築</a:t>
+            </a:r>
+          </a:p>
+        </p:txBody>
+      </p:sp>
+      <p:sp>
+        <p:nvSpPr>
+          <p:cNvPr id="25" name="Rounded Rectangle 24"/>
           <p:cNvSpPr/>
           <p:nvPr/>
         </p:nvSpPr>
@@ -4668,13 +4806,13 @@
       </p:sp>
       <p:sp>
         <p:nvSpPr>
-          <p:cNvPr id="20" name="TextBox 19"/>
+          <p:cNvPr id="26" name="TextBox 25"/>
           <p:cNvSpPr txBox="1"/>
           <p:nvPr/>
         </p:nvSpPr>
         <p:spPr>
           <a:xfrm>
-            <a:off x="1051560" y="3822191"/>
+            <a:off x="1051560" y="3813048"/>
             <a:ext cx="10058400" cy="457200"/>
           </a:xfrm>
           <a:prstGeom prst="rect">
@@ -4700,48 +4838,48 @@
               </a:spcAft>
             </a:pPr>
             <a:r>
-              <a:rPr sz="1700" b="1">
+              <a:rPr sz="1650" b="1">
                 <a:solidFill>
                   <a:srgbClr val="1A1D21"/>
                 </a:solidFill>
                 <a:latin typeface="Noto Sans JP"/>
                 <a:ea typeface="Noto Sans JP"/>
               </a:rPr>
-              <a:t>いま製造業は、建設業のように</a:t>
-            </a:r>
-            <a:r>
-              <a:rPr sz="1700" b="1">
+              <a:t>どのメガトレンドも、実現するには</a:t>
+            </a:r>
+            <a:r>
+              <a:rPr sz="1650" b="1">
                 <a:solidFill>
                   <a:srgbClr val="E60012"/>
                 </a:solidFill>
                 <a:latin typeface="Noto Sans JP"/>
                 <a:ea typeface="Noto Sans JP"/>
               </a:rPr>
-              <a:t>“現場だらけ”</a:t>
-            </a:r>
-            <a:r>
-              <a:rPr sz="1700" b="1">
+              <a:t>膨大な“設備”</a:t>
+            </a:r>
+            <a:r>
+              <a:rPr sz="1650" b="1">
                 <a:solidFill>
                   <a:srgbClr val="1A1D21"/>
                 </a:solidFill>
                 <a:latin typeface="Noto Sans JP"/>
                 <a:ea typeface="Noto Sans JP"/>
               </a:rPr>
-              <a:t>になっている。</a:t>
-            </a:r>
-          </a:p>
-        </p:txBody>
-      </p:sp>
-      <p:sp>
-        <p:nvSpPr>
-          <p:cNvPr id="21" name="TextBox 20"/>
+              <a:t>がいる。</a:t>
+            </a:r>
+          </a:p>
+        </p:txBody>
+      </p:sp>
+      <p:sp>
+        <p:nvSpPr>
+          <p:cNvPr id="27" name="TextBox 26"/>
           <p:cNvSpPr txBox="1"/>
           <p:nvPr/>
         </p:nvSpPr>
         <p:spPr>
           <a:xfrm>
-            <a:off x="1051560" y="4370832"/>
-            <a:ext cx="10058400" cy="411480"/>
+            <a:off x="1051560" y="4315968"/>
+            <a:ext cx="10058400" cy="457200"/>
           </a:xfrm>
           <a:prstGeom prst="rect">
             <a:avLst/>
@@ -4766,28 +4904,38 @@
               </a:spcAft>
             </a:pPr>
             <a:r>
-              <a:rPr sz="1250" b="0">
+              <a:rPr sz="1300" b="0">
                 <a:solidFill>
                   <a:srgbClr val="3C4148"/>
                 </a:solidFill>
                 <a:latin typeface="Noto Sans JP"/>
                 <a:ea typeface="Noto Sans JP"/>
               </a:rPr>
-              <a:t>＝ 我々が建設業で磨いた「現場管理」が、そのまま効く土俵が、製造業に新しく生まれている。</a:t>
-            </a:r>
-          </a:p>
-        </p:txBody>
-      </p:sp>
-      <p:sp>
-        <p:nvSpPr>
-          <p:cNvPr id="22" name="Rounded Rectangle 21"/>
+              <a:t>そして設備を作る・建てるのは——建設業だけでなく、</a:t>
+            </a:r>
+            <a:r>
+              <a:rPr sz="1300" b="1">
+                <a:solidFill>
+                  <a:srgbClr val="E60012"/>
+                </a:solidFill>
+                <a:latin typeface="Noto Sans JP"/>
+                <a:ea typeface="Noto Sans JP"/>
+              </a:rPr>
+              <a:t>重電・機械・電機など製造業がコア。</a:t>
+            </a:r>
+          </a:p>
+        </p:txBody>
+      </p:sp>
+      <p:sp>
+        <p:nvSpPr>
+          <p:cNvPr id="28" name="Rounded Rectangle 27"/>
           <p:cNvSpPr/>
           <p:nvPr/>
         </p:nvSpPr>
         <p:spPr>
           <a:xfrm>
-            <a:off x="777240" y="5074920"/>
-            <a:ext cx="10634472" cy="1143000"/>
+            <a:off x="777240" y="5029200"/>
+            <a:ext cx="10634472" cy="1188720"/>
           </a:xfrm>
           <a:prstGeom prst="roundRect">
             <a:avLst>
@@ -4795,12 +4943,10 @@
             </a:avLst>
           </a:prstGeom>
           <a:solidFill>
-            <a:srgbClr val="FDECEE"/>
+            <a:srgbClr val="E60012"/>
           </a:solidFill>
-          <a:ln w="12700">
-            <a:solidFill>
-              <a:srgbClr val="F3C7CD"/>
-            </a:solidFill>
+          <a:ln>
+            <a:noFill/>
           </a:ln>
           <a:effectLst/>
         </p:spPr>
@@ -4828,13 +4974,13 @@
       </p:sp>
       <p:sp>
         <p:nvSpPr>
-          <p:cNvPr id="23" name="TextBox 22"/>
+          <p:cNvPr id="29" name="TextBox 28"/>
           <p:cNvSpPr txBox="1"/>
           <p:nvPr/>
         </p:nvSpPr>
         <p:spPr>
           <a:xfrm>
-            <a:off x="1051560" y="5266944"/>
+            <a:off x="1051560" y="5193792"/>
             <a:ext cx="10058400" cy="457200"/>
           </a:xfrm>
           <a:prstGeom prst="rect">
@@ -4860,28 +5006,28 @@
               </a:spcAft>
             </a:pPr>
             <a:r>
-              <a:rPr sz="1550" b="1">
-                <a:solidFill>
-                  <a:srgbClr val="1A1D21"/>
+              <a:rPr sz="1650" b="1">
+                <a:solidFill>
+                  <a:srgbClr val="FFFFFF"/>
                 </a:solidFill>
                 <a:latin typeface="Noto Sans JP"/>
                 <a:ea typeface="Noto Sans JP"/>
               </a:rPr>
-              <a:t>しかもこれは、一過性のブームではない。</a:t>
-            </a:r>
-          </a:p>
-        </p:txBody>
-      </p:sp>
-      <p:sp>
-        <p:nvSpPr>
-          <p:cNvPr id="24" name="TextBox 23"/>
+              <a:t>この“設備”の市場が、いま圧倒的に広がっている。乗らない手はない。</a:t>
+            </a:r>
+          </a:p>
+        </p:txBody>
+      </p:sp>
+      <p:sp>
+        <p:nvSpPr>
+          <p:cNvPr id="30" name="TextBox 29"/>
           <p:cNvSpPr txBox="1"/>
           <p:nvPr/>
         </p:nvSpPr>
         <p:spPr>
           <a:xfrm>
-            <a:off x="1051560" y="5742432"/>
-            <a:ext cx="10058400" cy="411480"/>
+            <a:off x="1051560" y="5705856"/>
+            <a:ext cx="10058400" cy="457200"/>
           </a:xfrm>
           <a:prstGeom prst="rect">
             <a:avLst/>
@@ -4906,34 +5052,34 @@
               </a:spcAft>
             </a:pPr>
             <a:r>
-              <a:rPr sz="1250" b="0">
-                <a:solidFill>
-                  <a:srgbClr val="3C4148"/>
+              <a:rPr sz="1350" b="1">
+                <a:solidFill>
+                  <a:srgbClr val="FFD2D7"/>
                 </a:solidFill>
                 <a:latin typeface="Noto Sans JP"/>
                 <a:ea typeface="Noto Sans JP"/>
               </a:rPr>
-              <a:t>各社の受注残・設備投資計画・売上ガイダンスに裏打ちされた、数年〜十数年続く</a:t>
-            </a:r>
-            <a:r>
-              <a:rPr sz="1250" b="1">
-                <a:solidFill>
-                  <a:srgbClr val="E60012"/>
+              <a:t>→ 今日はその中で、最も勢いのある「</a:t>
+            </a:r>
+            <a:r>
+              <a:rPr sz="1350" b="1">
+                <a:solidFill>
+                  <a:srgbClr val="FFFFFF"/>
                 </a:solidFill>
                 <a:latin typeface="Noto Sans JP"/>
                 <a:ea typeface="Noto Sans JP"/>
               </a:rPr>
-              <a:t>構造需要</a:t>
-            </a:r>
-            <a:r>
-              <a:rPr sz="1250" b="0">
-                <a:solidFill>
-                  <a:srgbClr val="3C4148"/>
+              <a:t>AI</a:t>
+            </a:r>
+            <a:r>
+              <a:rPr sz="1350" b="1">
+                <a:solidFill>
+                  <a:srgbClr val="FFD2D7"/>
                 </a:solidFill>
                 <a:latin typeface="Noto Sans JP"/>
                 <a:ea typeface="Noto Sans JP"/>
               </a:rPr>
-              <a:t>だ。</a:t>
+              <a:t>」にフォーカスして話す。</a:t>
             </a:r>
           </a:p>
         </p:txBody>

</xml_diff>